<commit_message>
coding in agenetic ai upto theme geenration and aligning text
</commit_message>
<xml_diff>
--- a/savingfolder_output/FINAL_FROG_REPORT.pptx
+++ b/savingfolder_output/FINAL_FROG_REPORT.pptx
@@ -9,6 +9,9 @@
     <p:sldId id="257" r:id="rId8"/>
     <p:sldId id="258" r:id="rId9"/>
     <p:sldId id="259" r:id="rId10"/>
+    <p:sldId id="260" r:id="rId11"/>
+    <p:sldId id="261" r:id="rId12"/>
+    <p:sldId id="262" r:id="rId13"/>
   </p:sldIdLst>
   <p:sldSz cx="9144000" cy="6858000" type="screen4x3"/>
   <p:notesSz cx="6858000" cy="9144000"/>
@@ -3112,7 +3115,7 @@
                   <a:srgbClr val="0078D4"/>
                 </a:solidFill>
               </a:rPr>
-              <a:t>Life Cycle of a Frog</a:t>
+              <a:t>Create a 6-slide presentation on the Life Cycle of a Frog</a:t>
             </a:r>
           </a:p>
         </p:txBody>
@@ -3143,30 +3146,6 @@
           </a:p>
         </p:txBody>
       </p:sp>
-      <p:pic>
-        <p:nvPicPr>
-          <p:cNvPr id="4" name="Picture 3" descr="img_EggStage.jpg"/>
-          <p:cNvPicPr>
-            <a:picLocks noChangeAspect="1"/>
-          </p:cNvPicPr>
-          <p:nvPr/>
-        </p:nvPicPr>
-        <p:blipFill>
-          <a:blip r:embed="rId2"/>
-          <a:stretch>
-            <a:fillRect/>
-          </a:stretch>
-        </p:blipFill>
-        <p:spPr>
-          <a:xfrm>
-            <a:off x="5486400" y="1714500"/>
-            <a:ext cx="3200400" cy="4114800"/>
-          </a:xfrm>
-          <a:prstGeom prst="rect">
-            <a:avLst/>
-          </a:prstGeom>
-        </p:spPr>
-      </p:pic>
     </p:spTree>
   </p:cSld>
   <p:clrMapOvr>
@@ -3203,10 +3182,10 @@
             <a:r>
               <a:rPr sz="3000">
                 <a:solidFill>
-                  <a:srgbClr val="0078D4"/>
+                  <a:srgbClr val="1E90FF"/>
                 </a:solidFill>
               </a:rPr>
-              <a:t>Egg Stage</a:t>
+              <a:t>Egg Phase: Embryonic Development</a:t>
             </a:r>
           </a:p>
         </p:txBody>
@@ -3228,67 +3207,51 @@
           </a:xfrm>
         </p:spPr>
         <p:txBody>
-          <a:bodyPr/>
-          <a:lstStyle/>
-          <a:p>
-            <a:pPr/>
+          <a:bodyPr wrap="square">
+            <a:normAutofit/>
+          </a:bodyPr>
+          <a:lstStyle/>
+          <a:p>
+            <a:pPr>
+              <a:defRPr sz="1600"/>
+            </a:pPr>
             <a:r>
               <a:rPr>
                 <a:solidFill>
-                  <a:srgbClr val="0078D4"/>
+                  <a:srgbClr val="1E90FF"/>
                 </a:solidFill>
               </a:rPr>
-              <a:t>Frogs lay hundreds of eggs in water, often encased in a protective jelly-like substance to enhance survival.</a:t>
-            </a:r>
-          </a:p>
-          <a:p>
-            <a:pPr/>
+              <a:t>Frogs lay hundreds of eggs in water, often protected by a jelly-like substance.</a:t>
+            </a:r>
+          </a:p>
+          <a:p>
+            <a:pPr>
+              <a:defRPr sz="1600"/>
+            </a:pPr>
             <a:r>
               <a:rPr>
                 <a:solidFill>
-                  <a:srgbClr val="0078D4"/>
+                  <a:srgbClr val="1E90FF"/>
                 </a:solidFill>
               </a:rPr>
-              <a:t>The developmental period for frog eggs ranges from 6 to 21 days, during which they transform into larvae.</a:t>
-            </a:r>
-          </a:p>
-          <a:p>
-            <a:pPr/>
+              <a:t>Eggs develop over 6 to 21 days before hatching into larvae.</a:t>
+            </a:r>
+          </a:p>
+          <a:p>
+            <a:pPr>
+              <a:defRPr sz="1600"/>
+            </a:pPr>
             <a:r>
               <a:rPr>
                 <a:solidFill>
-                  <a:srgbClr val="0078D4"/>
+                  <a:srgbClr val="1E90FF"/>
                 </a:solidFill>
               </a:rPr>
-              <a:t>A cluster of frog eggs is referred to as 'frogspawn' and plays a crucial role in the species' reproductive strategy.</a:t>
-            </a:r>
-          </a:p>
-        </p:txBody>
-      </p:sp>
-      <p:pic>
-        <p:nvPicPr>
-          <p:cNvPr id="4" name="Picture 3" descr="img_TadpoleStage.jpg"/>
-          <p:cNvPicPr>
-            <a:picLocks noChangeAspect="1"/>
-          </p:cNvPicPr>
-          <p:nvPr/>
-        </p:nvPicPr>
-        <p:blipFill>
-          <a:blip r:embed="rId2"/>
-          <a:stretch>
-            <a:fillRect/>
-          </a:stretch>
-        </p:blipFill>
-        <p:spPr>
-          <a:xfrm>
-            <a:off x="5486400" y="1714500"/>
-            <a:ext cx="3200400" cy="4114800"/>
-          </a:xfrm>
-          <a:prstGeom prst="rect">
-            <a:avLst/>
-          </a:prstGeom>
-        </p:spPr>
-      </p:pic>
+              <a:t>The cluster of eggs is known as 'frogspawn'.</a:t>
+            </a:r>
+          </a:p>
+        </p:txBody>
+      </p:sp>
     </p:spTree>
   </p:cSld>
   <p:clrMapOvr>
@@ -3325,10 +3288,10 @@
             <a:r>
               <a:rPr sz="3000">
                 <a:solidFill>
-                  <a:srgbClr val="0078D4"/>
+                  <a:srgbClr val="1E90FF"/>
                 </a:solidFill>
               </a:rPr>
-              <a:t>Metamorphosis</a:t>
+              <a:t>The Tadpole: Swimming &amp; Growth</a:t>
             </a:r>
           </a:p>
         </p:txBody>
@@ -3350,185 +3313,47 @@
           </a:xfrm>
         </p:spPr>
         <p:txBody>
-          <a:bodyPr/>
-          <a:lstStyle/>
-          <a:p>
-            <a:pPr/>
+          <a:bodyPr wrap="square">
+            <a:normAutofit/>
+          </a:bodyPr>
+          <a:lstStyle/>
+          <a:p>
+            <a:pPr>
+              <a:defRPr sz="1600"/>
+            </a:pPr>
             <a:r>
               <a:rPr>
                 <a:solidFill>
-                  <a:srgbClr val="0078D4"/>
+                  <a:srgbClr val="1E90FF"/>
                 </a:solidFill>
               </a:rPr>
-              <a:t>(No facts found)</a:t>
-            </a:r>
-          </a:p>
-        </p:txBody>
-      </p:sp>
-      <p:pic>
-        <p:nvPicPr>
-          <p:cNvPr id="4" name="Picture 3" descr="img_Metamorphosis.jpg"/>
-          <p:cNvPicPr>
-            <a:picLocks noChangeAspect="1"/>
-          </p:cNvPicPr>
-          <p:nvPr/>
-        </p:nvPicPr>
-        <p:blipFill>
-          <a:blip r:embed="rId2"/>
-          <a:stretch>
-            <a:fillRect/>
-          </a:stretch>
-        </p:blipFill>
-        <p:spPr>
-          <a:xfrm>
-            <a:off x="5486400" y="1714500"/>
-            <a:ext cx="3200400" cy="4114800"/>
-          </a:xfrm>
-          <a:prstGeom prst="rect">
-            <a:avLst/>
-          </a:prstGeom>
-        </p:spPr>
-      </p:pic>
-      <p:sp>
-        <p:nvSpPr>
-          <p:cNvPr id="5" name="Rectangle 4"/>
-          <p:cNvSpPr/>
-          <p:nvPr/>
-        </p:nvSpPr>
-        <p:spPr>
-          <a:xfrm>
-            <a:off x="457200" y="2400300"/>
-            <a:ext cx="2331720" cy="822960"/>
-          </a:xfrm>
-          <a:prstGeom prst="rect">
-            <a:avLst/>
-          </a:prstGeom>
-          <a:solidFill>
-            <a:srgbClr val="F0F8FF"/>
-          </a:solidFill>
-          <a:ln>
-            <a:solidFill>
-              <a:srgbClr val="6495ED"/>
-            </a:solidFill>
-          </a:ln>
-        </p:spPr>
-        <p:style>
-          <a:lnRef idx="1">
-            <a:schemeClr val="accent1"/>
-          </a:lnRef>
-          <a:fillRef idx="3">
-            <a:schemeClr val="accent1"/>
-          </a:fillRef>
-          <a:effectRef idx="2">
-            <a:schemeClr val="accent1"/>
-          </a:effectRef>
-          <a:fontRef idx="minor">
-            <a:schemeClr val="lt1"/>
-          </a:fontRef>
-        </p:style>
-        <p:txBody>
-          <a:bodyPr rtlCol="0" anchor="ctr"/>
-          <a:lstStyle/>
-          <a:p>
-            <a:r>
-              <a:rPr sz="1100"/>
-              <a:t>During metamorphosis, the organism undergoes a transformation where hind legs and subsequently front legs develop, facilitating a shift to a terrestrial lifestyle.</a:t>
-            </a:r>
-          </a:p>
-        </p:txBody>
-      </p:sp>
-      <p:sp>
-        <p:nvSpPr>
-          <p:cNvPr id="6" name="Rectangle 5"/>
-          <p:cNvSpPr/>
-          <p:nvPr/>
-        </p:nvSpPr>
-        <p:spPr>
-          <a:xfrm>
-            <a:off x="3406140" y="2400300"/>
-            <a:ext cx="2331720" cy="822960"/>
-          </a:xfrm>
-          <a:prstGeom prst="rect">
-            <a:avLst/>
-          </a:prstGeom>
-          <a:solidFill>
-            <a:srgbClr val="F0F8FF"/>
-          </a:solidFill>
-          <a:ln>
-            <a:solidFill>
-              <a:srgbClr val="6495ED"/>
-            </a:solidFill>
-          </a:ln>
-        </p:spPr>
-        <p:style>
-          <a:lnRef idx="1">
-            <a:schemeClr val="accent1"/>
-          </a:lnRef>
-          <a:fillRef idx="3">
-            <a:schemeClr val="accent1"/>
-          </a:fillRef>
-          <a:effectRef idx="2">
-            <a:schemeClr val="accent1"/>
-          </a:effectRef>
-          <a:fontRef idx="minor">
-            <a:schemeClr val="lt1"/>
-          </a:fontRef>
-        </p:style>
-        <p:txBody>
-          <a:bodyPr rtlCol="0" anchor="ctr"/>
-          <a:lstStyle/>
-          <a:p>
-            <a:r>
-              <a:rPr sz="1100"/>
-              <a:t>As part of the metamorphosis process, the tail is gradually absorbed by the body, providing essential nutrients that support further development.</a:t>
-            </a:r>
-          </a:p>
-        </p:txBody>
-      </p:sp>
-      <p:sp>
-        <p:nvSpPr>
-          <p:cNvPr id="7" name="Rectangle 6"/>
-          <p:cNvSpPr/>
-          <p:nvPr/>
-        </p:nvSpPr>
-        <p:spPr>
-          <a:xfrm>
-            <a:off x="6355080" y="2400300"/>
-            <a:ext cx="2331720" cy="822960"/>
-          </a:xfrm>
-          <a:prstGeom prst="rect">
-            <a:avLst/>
-          </a:prstGeom>
-          <a:solidFill>
-            <a:srgbClr val="F0F8FF"/>
-          </a:solidFill>
-          <a:ln>
-            <a:solidFill>
-              <a:srgbClr val="6495ED"/>
-            </a:solidFill>
-          </a:ln>
-        </p:spPr>
-        <p:style>
-          <a:lnRef idx="1">
-            <a:schemeClr val="accent1"/>
-          </a:lnRef>
-          <a:fillRef idx="3">
-            <a:schemeClr val="accent1"/>
-          </a:fillRef>
-          <a:effectRef idx="2">
-            <a:schemeClr val="accent1"/>
-          </a:effectRef>
-          <a:fontRef idx="minor">
-            <a:schemeClr val="lt1"/>
-          </a:fontRef>
-        </p:style>
-        <p:txBody>
-          <a:bodyPr rtlCol="0" anchor="ctr"/>
-          <a:lstStyle/>
-          <a:p>
-            <a:r>
-              <a:rPr sz="1100"/>
-              <a:t>Metamorphosis involves the evolution of lungs to replace gills, enabling the organism to breathe air and adapt to new environmental conditions.</a:t>
+              <a:t>Tadpoles are purely aquatic larvae with gills and a long tail.</a:t>
+            </a:r>
+          </a:p>
+          <a:p>
+            <a:pPr>
+              <a:defRPr sz="1600"/>
+            </a:pPr>
+            <a:r>
+              <a:rPr>
+                <a:solidFill>
+                  <a:srgbClr val="1E90FF"/>
+                </a:solidFill>
+              </a:rPr>
+              <a:t>They primarily feed on algae and organic debris found in ponds.</a:t>
+            </a:r>
+          </a:p>
+          <a:p>
+            <a:pPr>
+              <a:defRPr sz="1600"/>
+            </a:pPr>
+            <a:r>
+              <a:rPr>
+                <a:solidFill>
+                  <a:srgbClr val="1E90FF"/>
+                </a:solidFill>
+              </a:rPr>
+              <a:t>Internal organs begin to develop during this stage, preparing for life on land.</a:t>
             </a:r>
           </a:p>
         </p:txBody>
@@ -3567,7 +3392,12 @@
           <a:lstStyle/>
           <a:p>
             <a:r>
-              <a:t>Adult Frog</a:t>
+              <a:rPr sz="3000">
+                <a:solidFill>
+                  <a:srgbClr val="1E90FF"/>
+                </a:solidFill>
+              </a:rPr>
+              <a:t>Metamorphosis: Major Transformation</a:t>
             </a:r>
           </a:p>
         </p:txBody>
@@ -3589,24 +3419,391 @@
           </a:xfrm>
         </p:spPr>
         <p:txBody>
-          <a:bodyPr/>
-          <a:lstStyle/>
-          <a:p>
-            <a:pPr/>
-            <a:r>
-              <a:t>Adult frogs are classified under the order Anura and are characterized by their fully developed hind legs, which are adapted for powerful jumping movements.</a:t>
-            </a:r>
-          </a:p>
-          <a:p>
-            <a:pPr/>
-            <a:r>
-              <a:t>Their permeable skin is a key feature of adult frogs, facilitating respiration and osmoregulation, but necessitating a moist environment to prevent desiccation.</a:t>
-            </a:r>
-          </a:p>
-          <a:p>
-            <a:pPr/>
-            <a:r>
-              <a:t>Carnivorous in nature, adult frogs employ a rapid tongue projection to capture insects and other small prey, showcasing their specialized feeding mechanism.</a:t>
+          <a:bodyPr wrap="square">
+            <a:normAutofit/>
+          </a:bodyPr>
+          <a:lstStyle/>
+          <a:p>
+            <a:pPr>
+              <a:defRPr sz="1600"/>
+            </a:pPr>
+            <a:r>
+              <a:rPr>
+                <a:solidFill>
+                  <a:srgbClr val="1E90FF"/>
+                </a:solidFill>
+              </a:rPr>
+              <a:t>This is the transformational stage where hind legs and then front legs grow.</a:t>
+            </a:r>
+          </a:p>
+          <a:p>
+            <a:pPr>
+              <a:defRPr sz="1600"/>
+            </a:pPr>
+            <a:r>
+              <a:rPr>
+                <a:solidFill>
+                  <a:srgbClr val="1E90FF"/>
+                </a:solidFill>
+              </a:rPr>
+              <a:t>The tail is slowly absorbed by the body to provide nutrients for development.</a:t>
+            </a:r>
+          </a:p>
+          <a:p>
+            <a:pPr>
+              <a:defRPr sz="1600"/>
+            </a:pPr>
+            <a:r>
+              <a:rPr>
+                <a:solidFill>
+                  <a:srgbClr val="1E90FF"/>
+                </a:solidFill>
+              </a:rPr>
+              <a:t>Lungs develop at this stage to replace gills for air breathing.</a:t>
+            </a:r>
+          </a:p>
+        </p:txBody>
+      </p:sp>
+    </p:spTree>
+  </p:cSld>
+  <p:clrMapOvr>
+    <a:masterClrMapping/>
+  </p:clrMapOvr>
+</p:sld>
+</file>
+
+<file path=ppt/slides/slide5.xml><?xml version="1.0" encoding="utf-8"?>
+<p:sld xmlns:a="http://schemas.openxmlformats.org/drawingml/2006/main" xmlns:p="http://schemas.openxmlformats.org/presentationml/2006/main" xmlns:r="http://schemas.openxmlformats.org/officeDocument/2006/relationships">
+  <p:cSld>
+    <p:spTree>
+      <p:nvGrpSpPr>
+        <p:cNvPr id="1" name=""/>
+        <p:cNvGrpSpPr/>
+        <p:nvPr/>
+      </p:nvGrpSpPr>
+      <p:grpSpPr/>
+      <p:sp>
+        <p:nvSpPr>
+          <p:cNvPr id="2" name="Title 1"/>
+          <p:cNvSpPr>
+            <a:spLocks noGrp="1"/>
+          </p:cNvSpPr>
+          <p:nvPr>
+            <p:ph type="title"/>
+          </p:nvPr>
+        </p:nvSpPr>
+        <p:spPr/>
+        <p:txBody>
+          <a:bodyPr/>
+          <a:lstStyle/>
+          <a:p>
+            <a:r>
+              <a:rPr sz="3000">
+                <a:solidFill>
+                  <a:srgbClr val="1E90FF"/>
+                </a:solidFill>
+              </a:rPr>
+              <a:t>The Froglet: Juvenile Stage</a:t>
+            </a:r>
+          </a:p>
+        </p:txBody>
+      </p:sp>
+      <p:sp>
+        <p:nvSpPr>
+          <p:cNvPr id="3" name="Content Placeholder 2"/>
+          <p:cNvSpPr>
+            <a:spLocks noGrp="1"/>
+          </p:cNvSpPr>
+          <p:nvPr>
+            <p:ph idx="1"/>
+          </p:nvPr>
+        </p:nvSpPr>
+        <p:spPr>
+          <a:xfrm>
+            <a:off x="0" y="0"/>
+            <a:ext cx="5486400" cy="0"/>
+          </a:xfrm>
+        </p:spPr>
+        <p:txBody>
+          <a:bodyPr wrap="square">
+            <a:normAutofit/>
+          </a:bodyPr>
+          <a:lstStyle/>
+          <a:p>
+            <a:pPr>
+              <a:defRPr sz="1600"/>
+            </a:pPr>
+            <a:r>
+              <a:rPr>
+                <a:solidFill>
+                  <a:srgbClr val="1E90FF"/>
+                </a:solidFill>
+              </a:rPr>
+              <a:t>A froglet resembles a miniature adult but still retains a small tail stump.</a:t>
+            </a:r>
+          </a:p>
+          <a:p>
+            <a:pPr>
+              <a:defRPr sz="1600"/>
+            </a:pPr>
+            <a:r>
+              <a:rPr>
+                <a:solidFill>
+                  <a:srgbClr val="1E90FF"/>
+                </a:solidFill>
+              </a:rPr>
+              <a:t>It begins to shift its diet from algae to small insects like flies.</a:t>
+            </a:r>
+          </a:p>
+          <a:p>
+            <a:pPr>
+              <a:defRPr sz="1600"/>
+            </a:pPr>
+            <a:r>
+              <a:rPr>
+                <a:solidFill>
+                  <a:srgbClr val="1E90FF"/>
+                </a:solidFill>
+              </a:rPr>
+              <a:t>Froglets begin to spend more time near the water's edge rather than deep inside.</a:t>
+            </a:r>
+          </a:p>
+        </p:txBody>
+      </p:sp>
+    </p:spTree>
+  </p:cSld>
+  <p:clrMapOvr>
+    <a:masterClrMapping/>
+  </p:clrMapOvr>
+</p:sld>
+</file>
+
+<file path=ppt/slides/slide6.xml><?xml version="1.0" encoding="utf-8"?>
+<p:sld xmlns:a="http://schemas.openxmlformats.org/drawingml/2006/main" xmlns:p="http://schemas.openxmlformats.org/presentationml/2006/main" xmlns:r="http://schemas.openxmlformats.org/officeDocument/2006/relationships">
+  <p:cSld>
+    <p:spTree>
+      <p:nvGrpSpPr>
+        <p:cNvPr id="1" name=""/>
+        <p:cNvGrpSpPr/>
+        <p:nvPr/>
+      </p:nvGrpSpPr>
+      <p:grpSpPr/>
+      <p:sp>
+        <p:nvSpPr>
+          <p:cNvPr id="2" name="Title 1"/>
+          <p:cNvSpPr>
+            <a:spLocks noGrp="1"/>
+          </p:cNvSpPr>
+          <p:nvPr>
+            <p:ph type="title"/>
+          </p:nvPr>
+        </p:nvSpPr>
+        <p:spPr/>
+        <p:txBody>
+          <a:bodyPr/>
+          <a:lstStyle/>
+          <a:p>
+            <a:r>
+              <a:rPr sz="3000">
+                <a:solidFill>
+                  <a:srgbClr val="1E90FF"/>
+                </a:solidFill>
+              </a:rPr>
+              <a:t>Adult Frog: Maturity &amp; Ecosystem</a:t>
+            </a:r>
+          </a:p>
+        </p:txBody>
+      </p:sp>
+      <p:sp>
+        <p:nvSpPr>
+          <p:cNvPr id="3" name="Content Placeholder 2"/>
+          <p:cNvSpPr>
+            <a:spLocks noGrp="1"/>
+          </p:cNvSpPr>
+          <p:nvPr>
+            <p:ph idx="1"/>
+          </p:nvPr>
+        </p:nvSpPr>
+        <p:spPr>
+          <a:xfrm>
+            <a:off x="0" y="0"/>
+            <a:ext cx="5486400" cy="0"/>
+          </a:xfrm>
+        </p:spPr>
+        <p:txBody>
+          <a:bodyPr wrap="square">
+            <a:normAutofit/>
+          </a:bodyPr>
+          <a:lstStyle/>
+          <a:p>
+            <a:pPr>
+              <a:defRPr sz="1600"/>
+            </a:pPr>
+            <a:r>
+              <a:rPr>
+                <a:solidFill>
+                  <a:srgbClr val="1E90FF"/>
+                </a:solidFill>
+              </a:rPr>
+              <a:t>Adult frogs are fully developed amphibians with powerful hind legs for jumping.</a:t>
+            </a:r>
+          </a:p>
+          <a:p>
+            <a:pPr>
+              <a:defRPr sz="1600"/>
+            </a:pPr>
+            <a:r>
+              <a:rPr>
+                <a:solidFill>
+                  <a:srgbClr val="1E90FF"/>
+                </a:solidFill>
+              </a:rPr>
+              <a:t>They have permeable skin that requires constant moisture to avoid dehydration.</a:t>
+            </a:r>
+          </a:p>
+          <a:p>
+            <a:pPr>
+              <a:defRPr sz="1600"/>
+            </a:pPr>
+            <a:r>
+              <a:rPr>
+                <a:solidFill>
+                  <a:srgbClr val="1E90FF"/>
+                </a:solidFill>
+              </a:rPr>
+              <a:t>Adults are carnivorous, using long, sticky tongues to catch prey.</a:t>
+            </a:r>
+          </a:p>
+        </p:txBody>
+      </p:sp>
+    </p:spTree>
+  </p:cSld>
+  <p:clrMapOvr>
+    <a:masterClrMapping/>
+  </p:clrMapOvr>
+</p:sld>
+</file>
+
+<file path=ppt/slides/slide7.xml><?xml version="1.0" encoding="utf-8"?>
+<p:sld xmlns:a="http://schemas.openxmlformats.org/drawingml/2006/main" xmlns:p="http://schemas.openxmlformats.org/presentationml/2006/main" xmlns:r="http://schemas.openxmlformats.org/officeDocument/2006/relationships">
+  <p:cSld>
+    <p:spTree>
+      <p:nvGrpSpPr>
+        <p:cNvPr id="1" name=""/>
+        <p:cNvGrpSpPr/>
+        <p:nvPr/>
+      </p:nvGrpSpPr>
+      <p:grpSpPr/>
+      <p:sp>
+        <p:nvSpPr>
+          <p:cNvPr id="2" name="Title 1"/>
+          <p:cNvSpPr>
+            <a:spLocks noGrp="1"/>
+          </p:cNvSpPr>
+          <p:nvPr>
+            <p:ph type="title"/>
+          </p:nvPr>
+        </p:nvSpPr>
+        <p:spPr/>
+        <p:txBody>
+          <a:bodyPr/>
+          <a:lstStyle/>
+          <a:p>
+            <a:r>
+              <a:rPr sz="3000">
+                <a:solidFill>
+                  <a:srgbClr val="1E90FF"/>
+                </a:solidFill>
+              </a:rPr>
+              <a:t>Life Cycle Challenges &amp; Survival Strategies</a:t>
+            </a:r>
+          </a:p>
+        </p:txBody>
+      </p:sp>
+      <p:sp>
+        <p:nvSpPr>
+          <p:cNvPr id="3" name="Content Placeholder 2"/>
+          <p:cNvSpPr>
+            <a:spLocks noGrp="1"/>
+          </p:cNvSpPr>
+          <p:nvPr>
+            <p:ph idx="1"/>
+          </p:nvPr>
+        </p:nvSpPr>
+        <p:spPr>
+          <a:xfrm>
+            <a:off x="0" y="0"/>
+            <a:ext cx="5486400" cy="0"/>
+          </a:xfrm>
+        </p:spPr>
+        <p:txBody>
+          <a:bodyPr wrap="square">
+            <a:normAutofit/>
+          </a:bodyPr>
+          <a:lstStyle/>
+          <a:p>
+            <a:pPr>
+              <a:defRPr sz="1600"/>
+            </a:pPr>
+            <a:r>
+              <a:rPr>
+                <a:solidFill>
+                  <a:srgbClr val="1E90FF"/>
+                </a:solidFill>
+              </a:rPr>
+              <a:t>Analysis of foundational principles related to Life of frog Life Challenges &amp; Survival Strategies.</a:t>
+            </a:r>
+          </a:p>
+          <a:p>
+            <a:pPr>
+              <a:defRPr sz="1600"/>
+            </a:pPr>
+            <a:r>
+              <a:rPr>
+                <a:solidFill>
+                  <a:srgbClr val="1E90FF"/>
+                </a:solidFill>
+              </a:rPr>
+              <a:t>Examination of key development stages and historical context.</a:t>
+            </a:r>
+          </a:p>
+          <a:p>
+            <a:pPr>
+              <a:defRPr sz="1600"/>
+            </a:pPr>
+            <a:r>
+              <a:rPr>
+                <a:solidFill>
+                  <a:srgbClr val="1E90FF"/>
+                </a:solidFill>
+              </a:rPr>
+              <a:t>Interactive applications and practical industry examples.</a:t>
+            </a:r>
+          </a:p>
+          <a:p>
+            <a:pPr>
+              <a:defRPr sz="1600"/>
+            </a:pPr>
+            <a:r>
+              <a:rPr>
+                <a:solidFill>
+                  <a:srgbClr val="1E90FF"/>
+                </a:solidFill>
+              </a:rPr>
+              <a:t>Summary of modern perspectives and future research directions.</a:t>
+            </a:r>
+          </a:p>
+          <a:p>
+            <a:pPr>
+              <a:defRPr sz="1600"/>
+            </a:pPr>
+            <a:r>
+              <a:rPr>
+                <a:solidFill>
+                  <a:srgbClr val="1E90FF"/>
+                </a:solidFill>
+              </a:rPr>
+              <a:t>Critical takeaways and essential synthesis for learners.</a:t>
             </a:r>
           </a:p>
         </p:txBody>

</xml_diff>